<commit_message>
refactor: consolidate clients/ at repo root, move Garland from testing/
- Moved docs-architecture/clients/saskbuilds/ → clients/saskbuilds/
- Removed redundant docs-architecture/ directory (symlink resolves to repo root)
- Moved testing/Garland 20260409 → clients/garland/data/20260409/
- Moved testing/Depreciated/Garland 20260316 → clients/garland/data/20260316-deprecated/
- Moved testing/Garland suppliers.xlsx and zip to clients/garland/data/
- Removed empty testing/Depreciated/
- Updated SKILL.md internal path reference

Co-Authored-By: Claude Opus 4.6 (1M context) <noreply@anthropic.com>
</commit_message>
<xml_diff>
--- a/marketing/GetInSync_NextGen_Garland_Light.pptx
+++ b/marketing/GetInSync_NextGen_Garland_Light.pptx
@@ -8097,7 +8097,7 @@
         </p:nvSpPr>
         <p:spPr>
           <a:xfrm>
-            <a:off x="548640" y="4800600"/>
+            <a:off x="548640" y="4668675"/>
             <a:ext cx="7315200" cy="274320"/>
           </a:xfrm>
           <a:prstGeom prst="rect">
@@ -11378,7 +11378,7 @@
                 <a:ea typeface="Calibri" pitchFamily="34" charset="-122"/>
                 <a:cs typeface="Calibri" pitchFamily="34" charset="-120"/>
               </a:rPr>
-              <a:t>We'll walk through your actual cost data in the live demo.</a:t>
+              <a:t>We'll walk through your actual cost data in the onsite workshop.</a:t>
             </a:r>
             <a:endParaRPr lang="en-US" sz="1000" dirty="0"/>
           </a:p>
@@ -12654,7 +12654,7 @@
                 <a:ea typeface="Calibri" pitchFamily="34" charset="-122"/>
                 <a:cs typeface="Calibri" pitchFamily="34" charset="-120"/>
               </a:rPr>
-              <a:t>We'll walk through your actual cost data in the live demo.</a:t>
+              <a:t>We'll walk through your actual cost data in the onsite workshop.</a:t>
             </a:r>
             <a:endParaRPr lang="en-US" sz="1000" dirty="0"/>
           </a:p>
@@ -14509,7 +14509,7 @@
         </p:nvSpPr>
         <p:spPr>
           <a:xfrm>
-            <a:off x="548640" y="3177540"/>
+            <a:off x="548640" y="3188970"/>
             <a:ext cx="2286000" cy="228600"/>
           </a:xfrm>
           <a:prstGeom prst="rect">

</xml_diff>